<commit_message>
updated day 3 slides
</commit_message>
<xml_diff>
--- a/presentations/Day 3 - Foundations of Applied Machine Learning/2_classic_ml_overview.pptx
+++ b/presentations/Day 3 - Foundations of Applied Machine Learning/2_classic_ml_overview.pptx
@@ -5,7 +5,7 @@
     <p:sldMasterId id="2147483648" r:id="rId1"/>
   </p:sldMasterIdLst>
   <p:notesMasterIdLst>
-    <p:notesMasterId r:id="rId18"/>
+    <p:notesMasterId r:id="rId20"/>
   </p:notesMasterIdLst>
   <p:sldIdLst>
     <p:sldId id="256" r:id="rId2"/>
@@ -20,10 +20,12 @@
     <p:sldId id="265" r:id="rId11"/>
     <p:sldId id="266" r:id="rId12"/>
     <p:sldId id="267" r:id="rId13"/>
-    <p:sldId id="268" r:id="rId14"/>
-    <p:sldId id="269" r:id="rId15"/>
-    <p:sldId id="270" r:id="rId16"/>
-    <p:sldId id="271" r:id="rId17"/>
+    <p:sldId id="272" r:id="rId14"/>
+    <p:sldId id="273" r:id="rId15"/>
+    <p:sldId id="268" r:id="rId16"/>
+    <p:sldId id="269" r:id="rId17"/>
+    <p:sldId id="270" r:id="rId18"/>
+    <p:sldId id="271" r:id="rId19"/>
   </p:sldIdLst>
   <p:sldSz cx="12192000" cy="6858000"/>
   <p:notesSz cx="6858000" cy="12192000"/>
@@ -593,7 +595,13 @@
   <p:cSld>
     <p:spTree>
       <p:nvGrpSpPr>
-        <p:cNvPr id="1" name=""/>
+        <p:cNvPr id="1" name="">
+          <a:extLst>
+            <a:ext uri="{FF2B5EF4-FFF2-40B4-BE49-F238E27FC236}">
+              <a16:creationId xmlns:a16="http://schemas.microsoft.com/office/drawing/2014/main" id="{27914CF5-223E-8FF0-DB17-DA52D49239A6}"/>
+            </a:ext>
+          </a:extLst>
+        </p:cNvPr>
         <p:cNvGrpSpPr/>
         <p:nvPr/>
       </p:nvGrpSpPr>
@@ -607,7 +615,13 @@
       </p:grpSpPr>
       <p:sp>
         <p:nvSpPr>
-          <p:cNvPr id="2" name="Slide Image Placeholder 1"/>
+          <p:cNvPr id="2" name="Slide Image Placeholder 1">
+            <a:extLst>
+              <a:ext uri="{FF2B5EF4-FFF2-40B4-BE49-F238E27FC236}">
+                <a16:creationId xmlns:a16="http://schemas.microsoft.com/office/drawing/2014/main" id="{AD6CBE21-2DEE-8F84-122C-439831883AB5}"/>
+              </a:ext>
+            </a:extLst>
+          </p:cNvPr>
           <p:cNvSpPr>
             <a:spLocks noGrp="1" noRot="1" noChangeAspect="1"/>
           </p:cNvSpPr>
@@ -619,7 +633,13 @@
       </p:sp>
       <p:sp>
         <p:nvSpPr>
-          <p:cNvPr id="3" name="Notes Placeholder 2"/>
+          <p:cNvPr id="3" name="Notes Placeholder 2">
+            <a:extLst>
+              <a:ext uri="{FF2B5EF4-FFF2-40B4-BE49-F238E27FC236}">
+                <a16:creationId xmlns:a16="http://schemas.microsoft.com/office/drawing/2014/main" id="{9EEE53E0-B93A-6662-393E-301D6B41D0CC}"/>
+              </a:ext>
+            </a:extLst>
+          </p:cNvPr>
           <p:cNvSpPr>
             <a:spLocks noGrp="1"/>
           </p:cNvSpPr>
@@ -638,7 +658,13 @@
       </p:sp>
       <p:sp>
         <p:nvSpPr>
-          <p:cNvPr id="4" name="Slide Number Placeholder 3"/>
+          <p:cNvPr id="4" name="Slide Number Placeholder 3">
+            <a:extLst>
+              <a:ext uri="{FF2B5EF4-FFF2-40B4-BE49-F238E27FC236}">
+                <a16:creationId xmlns:a16="http://schemas.microsoft.com/office/drawing/2014/main" id="{ABC684F0-E11E-51CA-4E48-A3417975C468}"/>
+              </a:ext>
+            </a:extLst>
+          </p:cNvPr>
           <p:cNvSpPr>
             <a:spLocks noGrp="1"/>
           </p:cNvSpPr>
@@ -662,7 +688,7 @@
     </p:spTree>
     <p:extLst>
       <p:ext uri="{BB962C8B-B14F-4D97-AF65-F5344CB8AC3E}">
-        <p14:creationId xmlns:p14="http://schemas.microsoft.com/office/powerpoint/2010/main" val="1024086991"/>
+        <p14:creationId xmlns:p14="http://schemas.microsoft.com/office/powerpoint/2010/main" val="3053113875"/>
       </p:ext>
     </p:extLst>
   </p:cSld>
@@ -677,7 +703,13 @@
   <p:cSld>
     <p:spTree>
       <p:nvGrpSpPr>
-        <p:cNvPr id="1" name=""/>
+        <p:cNvPr id="1" name="">
+          <a:extLst>
+            <a:ext uri="{FF2B5EF4-FFF2-40B4-BE49-F238E27FC236}">
+              <a16:creationId xmlns:a16="http://schemas.microsoft.com/office/drawing/2014/main" id="{672109A5-5E8B-A8BB-1331-DCE3B88B516D}"/>
+            </a:ext>
+          </a:extLst>
+        </p:cNvPr>
         <p:cNvGrpSpPr/>
         <p:nvPr/>
       </p:nvGrpSpPr>
@@ -691,7 +723,13 @@
       </p:grpSpPr>
       <p:sp>
         <p:nvSpPr>
-          <p:cNvPr id="2" name="Slide Image Placeholder 1"/>
+          <p:cNvPr id="2" name="Slide Image Placeholder 1">
+            <a:extLst>
+              <a:ext uri="{FF2B5EF4-FFF2-40B4-BE49-F238E27FC236}">
+                <a16:creationId xmlns:a16="http://schemas.microsoft.com/office/drawing/2014/main" id="{1C54A5A7-EED4-B149-316D-D90294F5977C}"/>
+              </a:ext>
+            </a:extLst>
+          </p:cNvPr>
           <p:cNvSpPr>
             <a:spLocks noGrp="1" noRot="1" noChangeAspect="1"/>
           </p:cNvSpPr>
@@ -703,7 +741,13 @@
       </p:sp>
       <p:sp>
         <p:nvSpPr>
-          <p:cNvPr id="3" name="Notes Placeholder 2"/>
+          <p:cNvPr id="3" name="Notes Placeholder 2">
+            <a:extLst>
+              <a:ext uri="{FF2B5EF4-FFF2-40B4-BE49-F238E27FC236}">
+                <a16:creationId xmlns:a16="http://schemas.microsoft.com/office/drawing/2014/main" id="{607FEA9F-3FB6-B6C7-5FF9-EDD3F7EAFB2D}"/>
+              </a:ext>
+            </a:extLst>
+          </p:cNvPr>
           <p:cNvSpPr>
             <a:spLocks noGrp="1"/>
           </p:cNvSpPr>
@@ -722,7 +766,13 @@
       </p:sp>
       <p:sp>
         <p:nvSpPr>
-          <p:cNvPr id="4" name="Slide Number Placeholder 3"/>
+          <p:cNvPr id="4" name="Slide Number Placeholder 3">
+            <a:extLst>
+              <a:ext uri="{FF2B5EF4-FFF2-40B4-BE49-F238E27FC236}">
+                <a16:creationId xmlns:a16="http://schemas.microsoft.com/office/drawing/2014/main" id="{94663C0E-003D-7A71-F5D6-FC5879DF2E44}"/>
+              </a:ext>
+            </a:extLst>
+          </p:cNvPr>
           <p:cNvSpPr>
             <a:spLocks noGrp="1"/>
           </p:cNvSpPr>
@@ -746,7 +796,7 @@
     </p:spTree>
     <p:extLst>
       <p:ext uri="{BB962C8B-B14F-4D97-AF65-F5344CB8AC3E}">
-        <p14:creationId xmlns:p14="http://schemas.microsoft.com/office/powerpoint/2010/main" val="1024086991"/>
+        <p14:creationId xmlns:p14="http://schemas.microsoft.com/office/powerpoint/2010/main" val="3538422313"/>
       </p:ext>
     </p:extLst>
   </p:cSld>
@@ -906,6 +956,174 @@
             <a:fld id="{F7021451-1387-4CA6-816F-3879F97B5CBC}" type="slidenum">
               <a:rPr lang="en-US"/>
               <a:t>16</a:t>
+            </a:fld>
+            <a:endParaRPr lang="en-US"/>
+          </a:p>
+        </p:txBody>
+      </p:sp>
+    </p:spTree>
+    <p:extLst>
+      <p:ext uri="{BB962C8B-B14F-4D97-AF65-F5344CB8AC3E}">
+        <p14:creationId xmlns:p14="http://schemas.microsoft.com/office/powerpoint/2010/main" val="1024086991"/>
+      </p:ext>
+    </p:extLst>
+  </p:cSld>
+  <p:clrMapOvr>
+    <a:masterClrMapping/>
+  </p:clrMapOvr>
+</p:notes>
+</file>
+
+<file path=ppt/notesSlides/notesSlide17.xml><?xml version="1.0" encoding="utf-8"?>
+<p:notes xmlns:a="http://schemas.openxmlformats.org/drawingml/2006/main" xmlns:r="http://schemas.openxmlformats.org/officeDocument/2006/relationships" xmlns:p="http://schemas.openxmlformats.org/presentationml/2006/main">
+  <p:cSld>
+    <p:spTree>
+      <p:nvGrpSpPr>
+        <p:cNvPr id="1" name=""/>
+        <p:cNvGrpSpPr/>
+        <p:nvPr/>
+      </p:nvGrpSpPr>
+      <p:grpSpPr>
+        <a:xfrm>
+          <a:off x="0" y="0"/>
+          <a:ext cx="0" cy="0"/>
+          <a:chOff x="0" y="0"/>
+          <a:chExt cx="0" cy="0"/>
+        </a:xfrm>
+      </p:grpSpPr>
+      <p:sp>
+        <p:nvSpPr>
+          <p:cNvPr id="2" name="Slide Image Placeholder 1"/>
+          <p:cNvSpPr>
+            <a:spLocks noGrp="1" noRot="1" noChangeAspect="1"/>
+          </p:cNvSpPr>
+          <p:nvPr>
+            <p:ph type="sldImg"/>
+          </p:nvPr>
+        </p:nvSpPr>
+        <p:spPr/>
+      </p:sp>
+      <p:sp>
+        <p:nvSpPr>
+          <p:cNvPr id="3" name="Notes Placeholder 2"/>
+          <p:cNvSpPr>
+            <a:spLocks noGrp="1"/>
+          </p:cNvSpPr>
+          <p:nvPr>
+            <p:ph type="body" idx="1"/>
+          </p:nvPr>
+        </p:nvSpPr>
+        <p:spPr/>
+        <p:txBody>
+          <a:bodyPr/>
+          <a:lstStyle/>
+          <a:p>
+            <a:endParaRPr lang="en-US" dirty="0"/>
+          </a:p>
+        </p:txBody>
+      </p:sp>
+      <p:sp>
+        <p:nvSpPr>
+          <p:cNvPr id="4" name="Slide Number Placeholder 3"/>
+          <p:cNvSpPr>
+            <a:spLocks noGrp="1"/>
+          </p:cNvSpPr>
+          <p:nvPr>
+            <p:ph type="sldNum" sz="quarter" idx="10"/>
+          </p:nvPr>
+        </p:nvSpPr>
+        <p:spPr/>
+        <p:txBody>
+          <a:bodyPr/>
+          <a:lstStyle/>
+          <a:p>
+            <a:fld id="{F7021451-1387-4CA6-816F-3879F97B5CBC}" type="slidenum">
+              <a:rPr lang="en-US"/>
+              <a:t>17</a:t>
+            </a:fld>
+            <a:endParaRPr lang="en-US"/>
+          </a:p>
+        </p:txBody>
+      </p:sp>
+    </p:spTree>
+    <p:extLst>
+      <p:ext uri="{BB962C8B-B14F-4D97-AF65-F5344CB8AC3E}">
+        <p14:creationId xmlns:p14="http://schemas.microsoft.com/office/powerpoint/2010/main" val="1024086991"/>
+      </p:ext>
+    </p:extLst>
+  </p:cSld>
+  <p:clrMapOvr>
+    <a:masterClrMapping/>
+  </p:clrMapOvr>
+</p:notes>
+</file>
+
+<file path=ppt/notesSlides/notesSlide18.xml><?xml version="1.0" encoding="utf-8"?>
+<p:notes xmlns:a="http://schemas.openxmlformats.org/drawingml/2006/main" xmlns:r="http://schemas.openxmlformats.org/officeDocument/2006/relationships" xmlns:p="http://schemas.openxmlformats.org/presentationml/2006/main">
+  <p:cSld>
+    <p:spTree>
+      <p:nvGrpSpPr>
+        <p:cNvPr id="1" name=""/>
+        <p:cNvGrpSpPr/>
+        <p:nvPr/>
+      </p:nvGrpSpPr>
+      <p:grpSpPr>
+        <a:xfrm>
+          <a:off x="0" y="0"/>
+          <a:ext cx="0" cy="0"/>
+          <a:chOff x="0" y="0"/>
+          <a:chExt cx="0" cy="0"/>
+        </a:xfrm>
+      </p:grpSpPr>
+      <p:sp>
+        <p:nvSpPr>
+          <p:cNvPr id="2" name="Slide Image Placeholder 1"/>
+          <p:cNvSpPr>
+            <a:spLocks noGrp="1" noRot="1" noChangeAspect="1"/>
+          </p:cNvSpPr>
+          <p:nvPr>
+            <p:ph type="sldImg"/>
+          </p:nvPr>
+        </p:nvSpPr>
+        <p:spPr/>
+      </p:sp>
+      <p:sp>
+        <p:nvSpPr>
+          <p:cNvPr id="3" name="Notes Placeholder 2"/>
+          <p:cNvSpPr>
+            <a:spLocks noGrp="1"/>
+          </p:cNvSpPr>
+          <p:nvPr>
+            <p:ph type="body" idx="1"/>
+          </p:nvPr>
+        </p:nvSpPr>
+        <p:spPr/>
+        <p:txBody>
+          <a:bodyPr/>
+          <a:lstStyle/>
+          <a:p>
+            <a:endParaRPr lang="en-US" dirty="0"/>
+          </a:p>
+        </p:txBody>
+      </p:sp>
+      <p:sp>
+        <p:nvSpPr>
+          <p:cNvPr id="4" name="Slide Number Placeholder 3"/>
+          <p:cNvSpPr>
+            <a:spLocks noGrp="1"/>
+          </p:cNvSpPr>
+          <p:nvPr>
+            <p:ph type="sldNum" sz="quarter" idx="10"/>
+          </p:nvPr>
+        </p:nvSpPr>
+        <p:spPr/>
+        <p:txBody>
+          <a:bodyPr/>
+          <a:lstStyle/>
+          <a:p>
+            <a:fld id="{F7021451-1387-4CA6-816F-3879F97B5CBC}" type="slidenum">
+              <a:rPr lang="en-US"/>
+              <a:t>18</a:t>
             </a:fld>
             <a:endParaRPr lang="en-US"/>
           </a:p>
@@ -4528,6 +4746,1408 @@
 
 <file path=ppt/slides/slide13.xml><?xml version="1.0" encoding="utf-8"?>
 <p:sld xmlns:a="http://schemas.openxmlformats.org/drawingml/2006/main" xmlns:r="http://schemas.openxmlformats.org/officeDocument/2006/relationships" xmlns:p="http://schemas.openxmlformats.org/presentationml/2006/main">
+  <p:cSld>
+    <p:bg>
+      <p:bgPr>
+        <a:solidFill>
+          <a:srgbClr val="FBFBFC"/>
+        </a:solidFill>
+        <a:effectLst/>
+      </p:bgPr>
+    </p:bg>
+    <p:spTree>
+      <p:nvGrpSpPr>
+        <p:cNvPr id="1" name="">
+          <a:extLst>
+            <a:ext uri="{FF2B5EF4-FFF2-40B4-BE49-F238E27FC236}">
+              <a16:creationId xmlns:a16="http://schemas.microsoft.com/office/drawing/2014/main" id="{0DF8D39A-8F3D-5D11-C104-2342FFDF95DD}"/>
+            </a:ext>
+          </a:extLst>
+        </p:cNvPr>
+        <p:cNvGrpSpPr/>
+        <p:nvPr/>
+      </p:nvGrpSpPr>
+      <p:grpSpPr>
+        <a:xfrm>
+          <a:off x="0" y="0"/>
+          <a:ext cx="0" cy="0"/>
+          <a:chOff x="0" y="0"/>
+          <a:chExt cx="0" cy="0"/>
+        </a:xfrm>
+      </p:grpSpPr>
+      <p:sp>
+        <p:nvSpPr>
+          <p:cNvPr id="2" name="Shape 0">
+            <a:extLst>
+              <a:ext uri="{FF2B5EF4-FFF2-40B4-BE49-F238E27FC236}">
+                <a16:creationId xmlns:a16="http://schemas.microsoft.com/office/drawing/2014/main" id="{81FD60D6-AE44-36EA-15D7-E46E2222DE5F}"/>
+              </a:ext>
+            </a:extLst>
+          </p:cNvPr>
+          <p:cNvSpPr/>
+          <p:nvPr/>
+        </p:nvSpPr>
+        <p:spPr>
+          <a:xfrm>
+            <a:off x="0" y="0"/>
+            <a:ext cx="12191695" cy="201168"/>
+          </a:xfrm>
+          <a:prstGeom prst="rect">
+            <a:avLst/>
+          </a:prstGeom>
+          <a:solidFill>
+            <a:srgbClr val="C8102E"/>
+          </a:solidFill>
+          <a:ln w="12700">
+            <a:solidFill>
+              <a:srgbClr val="C8102E">
+                <a:alpha val="0"/>
+              </a:srgbClr>
+            </a:solidFill>
+            <a:prstDash val="solid"/>
+          </a:ln>
+        </p:spPr>
+        <p:txBody>
+          <a:bodyPr/>
+          <a:lstStyle/>
+          <a:p>
+            <a:endParaRPr lang="en-US"/>
+          </a:p>
+        </p:txBody>
+      </p:sp>
+      <p:sp>
+        <p:nvSpPr>
+          <p:cNvPr id="3" name="Text 1">
+            <a:extLst>
+              <a:ext uri="{FF2B5EF4-FFF2-40B4-BE49-F238E27FC236}">
+                <a16:creationId xmlns:a16="http://schemas.microsoft.com/office/drawing/2014/main" id="{CF40F390-D8B2-C056-BB21-2671586FC3EE}"/>
+              </a:ext>
+            </a:extLst>
+          </p:cNvPr>
+          <p:cNvSpPr/>
+          <p:nvPr/>
+        </p:nvSpPr>
+        <p:spPr>
+          <a:xfrm>
+            <a:off x="502920" y="338328"/>
+            <a:ext cx="4389120" cy="201168"/>
+          </a:xfrm>
+          <a:prstGeom prst="rect">
+            <a:avLst/>
+          </a:prstGeom>
+          <a:noFill/>
+          <a:ln/>
+        </p:spPr>
+        <p:txBody>
+          <a:bodyPr wrap="square" lIns="0" tIns="0" rIns="0" bIns="0" rtlCol="0" anchor="ctr"/>
+          <a:lstStyle/>
+          <a:p>
+            <a:pPr marL="0" indent="0">
+              <a:buNone/>
+            </a:pPr>
+            <a:r>
+              <a:rPr lang="en-US" sz="750" b="1" dirty="0">
+                <a:solidFill>
+                  <a:srgbClr val="6B7280"/>
+                </a:solidFill>
+                <a:latin typeface="Aptos" pitchFamily="34" charset="0"/>
+                <a:ea typeface="Aptos" pitchFamily="34" charset="-122"/>
+                <a:cs typeface="Aptos" pitchFamily="34" charset="-120"/>
+              </a:rPr>
+              <a:t>APPLIED AI DESIGN WORKSHOP</a:t>
+            </a:r>
+            <a:endParaRPr lang="en-US" sz="750" dirty="0"/>
+          </a:p>
+        </p:txBody>
+      </p:sp>
+      <p:sp>
+        <p:nvSpPr>
+          <p:cNvPr id="5" name="Text 3">
+            <a:extLst>
+              <a:ext uri="{FF2B5EF4-FFF2-40B4-BE49-F238E27FC236}">
+                <a16:creationId xmlns:a16="http://schemas.microsoft.com/office/drawing/2014/main" id="{617B35BC-DC0B-FFFF-0996-33BC446AA91B}"/>
+              </a:ext>
+            </a:extLst>
+          </p:cNvPr>
+          <p:cNvSpPr/>
+          <p:nvPr/>
+        </p:nvSpPr>
+        <p:spPr>
+          <a:xfrm>
+            <a:off x="10561320" y="420624"/>
+            <a:ext cx="1097280" cy="292608"/>
+          </a:xfrm>
+          <a:prstGeom prst="rect">
+            <a:avLst/>
+          </a:prstGeom>
+          <a:noFill/>
+          <a:ln/>
+        </p:spPr>
+        <p:txBody>
+          <a:bodyPr wrap="square" lIns="0" tIns="0" rIns="0" bIns="0" rtlCol="0" anchor="ctr"/>
+          <a:lstStyle/>
+          <a:p>
+            <a:pPr marL="0" indent="0" algn="r">
+              <a:buNone/>
+            </a:pPr>
+            <a:r>
+              <a:rPr lang="en-US" sz="1000" dirty="0">
+                <a:solidFill>
+                  <a:srgbClr val="6B7280"/>
+                </a:solidFill>
+              </a:rPr>
+              <a:t>Session 2</a:t>
+            </a:r>
+            <a:endParaRPr lang="en-US" sz="1000" dirty="0"/>
+          </a:p>
+        </p:txBody>
+      </p:sp>
+      <p:sp>
+        <p:nvSpPr>
+          <p:cNvPr id="19" name="Text 17">
+            <a:extLst>
+              <a:ext uri="{FF2B5EF4-FFF2-40B4-BE49-F238E27FC236}">
+                <a16:creationId xmlns:a16="http://schemas.microsoft.com/office/drawing/2014/main" id="{026AEA52-7B1F-D1BB-6597-C0F177E32978}"/>
+              </a:ext>
+            </a:extLst>
+          </p:cNvPr>
+          <p:cNvSpPr/>
+          <p:nvPr/>
+        </p:nvSpPr>
+        <p:spPr>
+          <a:xfrm>
+            <a:off x="11539728" y="6446520"/>
+            <a:ext cx="274320" cy="182880"/>
+          </a:xfrm>
+          <a:prstGeom prst="rect">
+            <a:avLst/>
+          </a:prstGeom>
+          <a:noFill/>
+          <a:ln/>
+        </p:spPr>
+        <p:txBody>
+          <a:bodyPr wrap="square" lIns="0" tIns="0" rIns="0" bIns="0" rtlCol="0" anchor="ctr"/>
+          <a:lstStyle/>
+          <a:p>
+            <a:pPr marL="0" indent="0" algn="r">
+              <a:buNone/>
+            </a:pPr>
+            <a:r>
+              <a:rPr lang="en-US" sz="800" dirty="0">
+                <a:solidFill>
+                  <a:srgbClr val="9CA3AF"/>
+                </a:solidFill>
+              </a:rPr>
+              <a:t>15</a:t>
+            </a:r>
+            <a:endParaRPr lang="en-US" sz="800" dirty="0"/>
+          </a:p>
+        </p:txBody>
+      </p:sp>
+      <p:sp>
+        <p:nvSpPr>
+          <p:cNvPr id="21" name="Text 0">
+            <a:extLst>
+              <a:ext uri="{FF2B5EF4-FFF2-40B4-BE49-F238E27FC236}">
+                <a16:creationId xmlns:a16="http://schemas.microsoft.com/office/drawing/2014/main" id="{E3D9647D-194F-D697-5B6A-4B1FA2BF78D0}"/>
+              </a:ext>
+            </a:extLst>
+          </p:cNvPr>
+          <p:cNvSpPr/>
+          <p:nvPr/>
+        </p:nvSpPr>
+        <p:spPr>
+          <a:xfrm>
+            <a:off x="548640" y="1042416"/>
+            <a:ext cx="10789920" cy="457200"/>
+          </a:xfrm>
+          <a:prstGeom prst="rect">
+            <a:avLst/>
+          </a:prstGeom>
+          <a:noFill/>
+          <a:ln/>
+        </p:spPr>
+        <p:txBody>
+          <a:bodyPr wrap="square" lIns="0" tIns="0" rIns="0" bIns="0" rtlCol="0" anchor="ctr">
+            <a:normAutofit/>
+          </a:bodyPr>
+          <a:lstStyle/>
+          <a:p>
+            <a:pPr marL="0" indent="0">
+              <a:buNone/>
+            </a:pPr>
+            <a:r>
+              <a:rPr lang="en-US" sz="2500" b="1" dirty="0">
+                <a:solidFill>
+                  <a:srgbClr val="12355B"/>
+                </a:solidFill>
+                <a:latin typeface="Aptos Display" pitchFamily="34" charset="0"/>
+                <a:ea typeface="Aptos Display" pitchFamily="34" charset="-122"/>
+                <a:cs typeface="Aptos Display" pitchFamily="34" charset="-120"/>
+              </a:rPr>
+              <a:t>Session 2 technical skill: visualize before modeling</a:t>
+            </a:r>
+            <a:endParaRPr lang="en-US" sz="2500" dirty="0"/>
+          </a:p>
+        </p:txBody>
+      </p:sp>
+      <p:sp>
+        <p:nvSpPr>
+          <p:cNvPr id="23" name="Text 1">
+            <a:extLst>
+              <a:ext uri="{FF2B5EF4-FFF2-40B4-BE49-F238E27FC236}">
+                <a16:creationId xmlns:a16="http://schemas.microsoft.com/office/drawing/2014/main" id="{347A4386-F352-CA04-60E9-2396B8A90ADD}"/>
+              </a:ext>
+            </a:extLst>
+          </p:cNvPr>
+          <p:cNvSpPr/>
+          <p:nvPr/>
+        </p:nvSpPr>
+        <p:spPr>
+          <a:xfrm>
+            <a:off x="566928" y="1563624"/>
+            <a:ext cx="10241280" cy="320040"/>
+          </a:xfrm>
+          <a:prstGeom prst="rect">
+            <a:avLst/>
+          </a:prstGeom>
+          <a:noFill/>
+          <a:ln/>
+        </p:spPr>
+        <p:txBody>
+          <a:bodyPr wrap="square" lIns="0" tIns="0" rIns="0" bIns="0" rtlCol="0" anchor="ctr">
+            <a:normAutofit/>
+          </a:bodyPr>
+          <a:lstStyle/>
+          <a:p>
+            <a:pPr marL="0" indent="0">
+              <a:buNone/>
+            </a:pPr>
+            <a:r>
+              <a:rPr lang="en-US" sz="1150" dirty="0">
+                <a:solidFill>
+                  <a:srgbClr val="4B5563"/>
+                </a:solidFill>
+              </a:rPr>
+              <a:t>Goal: use quick plots to understand relationships, distributions, and target balance.</a:t>
+            </a:r>
+            <a:endParaRPr lang="en-US" sz="1150" dirty="0"/>
+          </a:p>
+        </p:txBody>
+      </p:sp>
+      <p:pic>
+        <p:nvPicPr>
+          <p:cNvPr id="25" name="Image 0" descr="/mnt/data/session0_python_data_tools/assets/iris_scatter.png">
+            <a:extLst>
+              <a:ext uri="{FF2B5EF4-FFF2-40B4-BE49-F238E27FC236}">
+                <a16:creationId xmlns:a16="http://schemas.microsoft.com/office/drawing/2014/main" id="{6E8F3759-8CB3-3ECB-B9A2-9D4765313599}"/>
+              </a:ext>
+            </a:extLst>
+          </p:cNvPr>
+          <p:cNvPicPr>
+            <a:picLocks noChangeAspect="1"/>
+          </p:cNvPicPr>
+          <p:nvPr/>
+        </p:nvPicPr>
+        <p:blipFill>
+          <a:blip r:embed="rId3"/>
+          <a:srcRect t="741" b="741"/>
+          <a:stretch/>
+        </p:blipFill>
+        <p:spPr>
+          <a:xfrm>
+            <a:off x="658368" y="1892808"/>
+            <a:ext cx="4937760" cy="3474720"/>
+          </a:xfrm>
+          <a:prstGeom prst="rect">
+            <a:avLst/>
+          </a:prstGeom>
+        </p:spPr>
+      </p:pic>
+      <p:sp>
+        <p:nvSpPr>
+          <p:cNvPr id="27" name="Shape 2">
+            <a:extLst>
+              <a:ext uri="{FF2B5EF4-FFF2-40B4-BE49-F238E27FC236}">
+                <a16:creationId xmlns:a16="http://schemas.microsoft.com/office/drawing/2014/main" id="{B9699966-609A-7FC0-E509-50B62F24A810}"/>
+              </a:ext>
+            </a:extLst>
+          </p:cNvPr>
+          <p:cNvSpPr/>
+          <p:nvPr/>
+        </p:nvSpPr>
+        <p:spPr>
+          <a:xfrm>
+            <a:off x="6080760" y="2048256"/>
+            <a:ext cx="4937760" cy="1554480"/>
+          </a:xfrm>
+          <a:prstGeom prst="roundRect">
+            <a:avLst>
+              <a:gd name="adj" fmla="val 3529"/>
+            </a:avLst>
+          </a:prstGeom>
+          <a:solidFill>
+            <a:srgbClr val="111827"/>
+          </a:solidFill>
+          <a:ln w="12700">
+            <a:solidFill>
+              <a:srgbClr val="111827"/>
+            </a:solidFill>
+            <a:prstDash val="solid"/>
+          </a:ln>
+        </p:spPr>
+        <p:txBody>
+          <a:bodyPr/>
+          <a:lstStyle/>
+          <a:p>
+            <a:endParaRPr lang="en-US"/>
+          </a:p>
+        </p:txBody>
+      </p:sp>
+      <p:sp>
+        <p:nvSpPr>
+          <p:cNvPr id="29" name="Text 3">
+            <a:extLst>
+              <a:ext uri="{FF2B5EF4-FFF2-40B4-BE49-F238E27FC236}">
+                <a16:creationId xmlns:a16="http://schemas.microsoft.com/office/drawing/2014/main" id="{43041ED0-DCE7-D025-F894-636A82BD55A5}"/>
+              </a:ext>
+            </a:extLst>
+          </p:cNvPr>
+          <p:cNvSpPr/>
+          <p:nvPr/>
+        </p:nvSpPr>
+        <p:spPr>
+          <a:xfrm>
+            <a:off x="6245352" y="2176272"/>
+            <a:ext cx="4608576" cy="1298448"/>
+          </a:xfrm>
+          <a:prstGeom prst="rect">
+            <a:avLst/>
+          </a:prstGeom>
+          <a:noFill/>
+          <a:ln/>
+        </p:spPr>
+        <p:txBody>
+          <a:bodyPr wrap="square" lIns="254" tIns="254" rIns="254" bIns="254" rtlCol="0" anchor="ctr">
+            <a:normAutofit/>
+          </a:bodyPr>
+          <a:lstStyle/>
+          <a:p>
+            <a:pPr marL="0" indent="0">
+              <a:buNone/>
+            </a:pPr>
+            <a:r>
+              <a:rPr lang="en-US" sz="920" dirty="0">
+                <a:solidFill>
+                  <a:srgbClr val="E5E7EB"/>
+                </a:solidFill>
+                <a:latin typeface="Cascadia Mono" pitchFamily="34" charset="0"/>
+                <a:ea typeface="Cascadia Mono" pitchFamily="34" charset="-122"/>
+                <a:cs typeface="Cascadia Mono" pitchFamily="34" charset="-120"/>
+              </a:rPr>
+              <a:t>import seaborn as sns</a:t>
+            </a:r>
+            <a:endParaRPr lang="en-US" sz="920" dirty="0"/>
+          </a:p>
+          <a:p>
+            <a:pPr marL="0" indent="0">
+              <a:buNone/>
+            </a:pPr>
+            <a:r>
+              <a:rPr lang="en-US" sz="920" dirty="0">
+                <a:solidFill>
+                  <a:srgbClr val="E5E7EB"/>
+                </a:solidFill>
+                <a:latin typeface="Cascadia Mono" pitchFamily="34" charset="0"/>
+                <a:ea typeface="Cascadia Mono" pitchFamily="34" charset="-122"/>
+                <a:cs typeface="Cascadia Mono" pitchFamily="34" charset="-120"/>
+              </a:rPr>
+              <a:t>import matplotlib.pyplot as plt</a:t>
+            </a:r>
+            <a:endParaRPr lang="en-US" sz="920" dirty="0"/>
+          </a:p>
+          <a:p>
+            <a:pPr marL="0" indent="0">
+              <a:buNone/>
+            </a:pPr>
+            <a:endParaRPr lang="en-US" sz="920" dirty="0"/>
+          </a:p>
+          <a:p>
+            <a:pPr marL="0" indent="0">
+              <a:buNone/>
+            </a:pPr>
+            <a:r>
+              <a:rPr lang="en-US" sz="920" dirty="0">
+                <a:solidFill>
+                  <a:srgbClr val="E5E7EB"/>
+                </a:solidFill>
+                <a:latin typeface="Cascadia Mono" pitchFamily="34" charset="0"/>
+                <a:ea typeface="Cascadia Mono" pitchFamily="34" charset="-122"/>
+                <a:cs typeface="Cascadia Mono" pitchFamily="34" charset="-120"/>
+              </a:rPr>
+              <a:t>sns.scatterplot(data=df,</a:t>
+            </a:r>
+            <a:endParaRPr lang="en-US" sz="920" dirty="0"/>
+          </a:p>
+          <a:p>
+            <a:pPr marL="0" indent="0">
+              <a:buNone/>
+            </a:pPr>
+            <a:r>
+              <a:rPr lang="en-US" sz="920" dirty="0">
+                <a:solidFill>
+                  <a:srgbClr val="E5E7EB"/>
+                </a:solidFill>
+                <a:latin typeface="Cascadia Mono" pitchFamily="34" charset="0"/>
+                <a:ea typeface="Cascadia Mono" pitchFamily="34" charset="-122"/>
+                <a:cs typeface="Cascadia Mono" pitchFamily="34" charset="-120"/>
+              </a:rPr>
+              <a:t>  x="PetalLength_cm",</a:t>
+            </a:r>
+            <a:endParaRPr lang="en-US" sz="920" dirty="0"/>
+          </a:p>
+          <a:p>
+            <a:pPr marL="0" indent="0">
+              <a:buNone/>
+            </a:pPr>
+            <a:r>
+              <a:rPr lang="en-US" sz="920" dirty="0">
+                <a:solidFill>
+                  <a:srgbClr val="E5E7EB"/>
+                </a:solidFill>
+                <a:latin typeface="Cascadia Mono" pitchFamily="34" charset="0"/>
+                <a:ea typeface="Cascadia Mono" pitchFamily="34" charset="-122"/>
+                <a:cs typeface="Cascadia Mono" pitchFamily="34" charset="-120"/>
+              </a:rPr>
+              <a:t>  y="PetalWidth_cm",</a:t>
+            </a:r>
+            <a:endParaRPr lang="en-US" sz="920" dirty="0"/>
+          </a:p>
+          <a:p>
+            <a:pPr marL="0" indent="0">
+              <a:buNone/>
+            </a:pPr>
+            <a:r>
+              <a:rPr lang="en-US" sz="920" dirty="0">
+                <a:solidFill>
+                  <a:srgbClr val="E5E7EB"/>
+                </a:solidFill>
+                <a:latin typeface="Cascadia Mono" pitchFamily="34" charset="0"/>
+                <a:ea typeface="Cascadia Mono" pitchFamily="34" charset="-122"/>
+                <a:cs typeface="Cascadia Mono" pitchFamily="34" charset="-120"/>
+              </a:rPr>
+              <a:t>  hue="Species")</a:t>
+            </a:r>
+            <a:endParaRPr lang="en-US" sz="920" dirty="0"/>
+          </a:p>
+          <a:p>
+            <a:pPr marL="0" indent="0">
+              <a:buNone/>
+            </a:pPr>
+            <a:r>
+              <a:rPr lang="en-US" sz="920" dirty="0">
+                <a:solidFill>
+                  <a:srgbClr val="E5E7EB"/>
+                </a:solidFill>
+                <a:latin typeface="Cascadia Mono" pitchFamily="34" charset="0"/>
+                <a:ea typeface="Cascadia Mono" pitchFamily="34" charset="-122"/>
+                <a:cs typeface="Cascadia Mono" pitchFamily="34" charset="-120"/>
+              </a:rPr>
+              <a:t>plt.show()</a:t>
+            </a:r>
+            <a:endParaRPr lang="en-US" sz="920" dirty="0"/>
+          </a:p>
+        </p:txBody>
+      </p:sp>
+      <p:sp>
+        <p:nvSpPr>
+          <p:cNvPr id="31" name="Text 4">
+            <a:extLst>
+              <a:ext uri="{FF2B5EF4-FFF2-40B4-BE49-F238E27FC236}">
+                <a16:creationId xmlns:a16="http://schemas.microsoft.com/office/drawing/2014/main" id="{165932B5-2F08-C0BB-DBAE-6211A6566F14}"/>
+              </a:ext>
+            </a:extLst>
+          </p:cNvPr>
+          <p:cNvSpPr/>
+          <p:nvPr/>
+        </p:nvSpPr>
+        <p:spPr>
+          <a:xfrm>
+            <a:off x="6217920" y="4123944"/>
+            <a:ext cx="4617720" cy="1143000"/>
+          </a:xfrm>
+          <a:prstGeom prst="rect">
+            <a:avLst/>
+          </a:prstGeom>
+          <a:noFill/>
+          <a:ln/>
+        </p:spPr>
+        <p:txBody>
+          <a:bodyPr wrap="square" lIns="508" tIns="508" rIns="508" bIns="508" rtlCol="0" anchor="t">
+            <a:normAutofit/>
+          </a:bodyPr>
+          <a:lstStyle/>
+          <a:p>
+            <a:pPr marL="152400" indent="-152400">
+              <a:buSzPct val="100000"/>
+              <a:buChar char="•"/>
+            </a:pPr>
+            <a:r>
+              <a:rPr lang="en-US" sz="1250" dirty="0">
+                <a:solidFill>
+                  <a:srgbClr val="4B5563"/>
+                </a:solidFill>
+                <a:latin typeface="Aptos" pitchFamily="34" charset="0"/>
+                <a:ea typeface="Aptos" pitchFamily="34" charset="-122"/>
+                <a:cs typeface="Aptos" pitchFamily="34" charset="-120"/>
+              </a:rPr>
+              <a:t>Do classes appear separable?</a:t>
+            </a:r>
+            <a:endParaRPr lang="en-US" sz="1250" dirty="0"/>
+          </a:p>
+          <a:p>
+            <a:pPr marL="152400" indent="-152400">
+              <a:buSzPct val="100000"/>
+              <a:buChar char="•"/>
+            </a:pPr>
+            <a:r>
+              <a:rPr lang="en-US" sz="1250" dirty="0">
+                <a:solidFill>
+                  <a:srgbClr val="4B5563"/>
+                </a:solidFill>
+                <a:latin typeface="Aptos" pitchFamily="34" charset="0"/>
+                <a:ea typeface="Aptos" pitchFamily="34" charset="-122"/>
+                <a:cs typeface="Aptos" pitchFamily="34" charset="-120"/>
+              </a:rPr>
+              <a:t>Are there obvious outliers?</a:t>
+            </a:r>
+            <a:endParaRPr lang="en-US" sz="1250" dirty="0"/>
+          </a:p>
+          <a:p>
+            <a:pPr marL="152400" indent="-152400">
+              <a:buSzPct val="100000"/>
+              <a:buChar char="•"/>
+            </a:pPr>
+            <a:r>
+              <a:rPr lang="en-US" sz="1250" dirty="0">
+                <a:solidFill>
+                  <a:srgbClr val="4B5563"/>
+                </a:solidFill>
+                <a:latin typeface="Aptos" pitchFamily="34" charset="0"/>
+                <a:ea typeface="Aptos" pitchFamily="34" charset="-122"/>
+                <a:cs typeface="Aptos" pitchFamily="34" charset="-120"/>
+              </a:rPr>
+              <a:t>Is the relationship linear or nonlinear?</a:t>
+            </a:r>
+            <a:endParaRPr lang="en-US" sz="1250" dirty="0"/>
+          </a:p>
+          <a:p>
+            <a:pPr marL="152400" indent="-152400">
+              <a:buSzPct val="100000"/>
+              <a:buChar char="•"/>
+            </a:pPr>
+            <a:r>
+              <a:rPr lang="en-US" sz="1250" dirty="0">
+                <a:solidFill>
+                  <a:srgbClr val="4B5563"/>
+                </a:solidFill>
+                <a:latin typeface="Aptos" pitchFamily="34" charset="0"/>
+                <a:ea typeface="Aptos" pitchFamily="34" charset="-122"/>
+                <a:cs typeface="Aptos" pitchFamily="34" charset="-120"/>
+              </a:rPr>
+              <a:t>What should not be concluded from the plot?</a:t>
+            </a:r>
+            <a:endParaRPr lang="en-US" sz="1250" dirty="0"/>
+          </a:p>
+        </p:txBody>
+      </p:sp>
+      <p:sp>
+        <p:nvSpPr>
+          <p:cNvPr id="33" name="Shape 5">
+            <a:extLst>
+              <a:ext uri="{FF2B5EF4-FFF2-40B4-BE49-F238E27FC236}">
+                <a16:creationId xmlns:a16="http://schemas.microsoft.com/office/drawing/2014/main" id="{88589D4E-2AF5-C9F2-AF29-E35FD0A91E05}"/>
+              </a:ext>
+            </a:extLst>
+          </p:cNvPr>
+          <p:cNvSpPr/>
+          <p:nvPr/>
+        </p:nvSpPr>
+        <p:spPr>
+          <a:xfrm>
+            <a:off x="713232" y="5797296"/>
+            <a:ext cx="1417320" cy="292608"/>
+          </a:xfrm>
+          <a:prstGeom prst="roundRect">
+            <a:avLst>
+              <a:gd name="adj" fmla="val 25000"/>
+            </a:avLst>
+          </a:prstGeom>
+          <a:solidFill>
+            <a:srgbClr val="0E7490"/>
+          </a:solidFill>
+          <a:ln w="12700">
+            <a:solidFill>
+              <a:srgbClr val="0E7490"/>
+            </a:solidFill>
+            <a:prstDash val="solid"/>
+          </a:ln>
+        </p:spPr>
+        <p:txBody>
+          <a:bodyPr/>
+          <a:lstStyle/>
+          <a:p>
+            <a:endParaRPr lang="en-US"/>
+          </a:p>
+        </p:txBody>
+      </p:sp>
+      <p:sp>
+        <p:nvSpPr>
+          <p:cNvPr id="35" name="Text 6">
+            <a:extLst>
+              <a:ext uri="{FF2B5EF4-FFF2-40B4-BE49-F238E27FC236}">
+                <a16:creationId xmlns:a16="http://schemas.microsoft.com/office/drawing/2014/main" id="{2C740831-B613-FA3A-EFD7-92BC25CEA880}"/>
+              </a:ext>
+            </a:extLst>
+          </p:cNvPr>
+          <p:cNvSpPr/>
+          <p:nvPr/>
+        </p:nvSpPr>
+        <p:spPr>
+          <a:xfrm>
+            <a:off x="713232" y="5865876"/>
+            <a:ext cx="1417320" cy="128016"/>
+          </a:xfrm>
+          <a:prstGeom prst="rect">
+            <a:avLst/>
+          </a:prstGeom>
+          <a:noFill/>
+          <a:ln/>
+        </p:spPr>
+        <p:txBody>
+          <a:bodyPr wrap="square" lIns="0" tIns="0" rIns="0" bIns="0" rtlCol="0" anchor="ctr"/>
+          <a:lstStyle/>
+          <a:p>
+            <a:pPr marL="0" indent="0" algn="ctr">
+              <a:buNone/>
+            </a:pPr>
+            <a:r>
+              <a:rPr lang="en-US" sz="850" b="1" dirty="0">
+                <a:solidFill>
+                  <a:srgbClr val="FFFFFF"/>
+                </a:solidFill>
+              </a:rPr>
+              <a:t>Session 2 notebook</a:t>
+            </a:r>
+            <a:endParaRPr lang="en-US" sz="850" dirty="0"/>
+          </a:p>
+        </p:txBody>
+      </p:sp>
+      <p:sp>
+        <p:nvSpPr>
+          <p:cNvPr id="37" name="Text 7">
+            <a:extLst>
+              <a:ext uri="{FF2B5EF4-FFF2-40B4-BE49-F238E27FC236}">
+                <a16:creationId xmlns:a16="http://schemas.microsoft.com/office/drawing/2014/main" id="{82246A8A-B968-E1C4-56AD-E3B9AF9BF0E7}"/>
+              </a:ext>
+            </a:extLst>
+          </p:cNvPr>
+          <p:cNvSpPr/>
+          <p:nvPr/>
+        </p:nvSpPr>
+        <p:spPr>
+          <a:xfrm>
+            <a:off x="2267712" y="5833872"/>
+            <a:ext cx="3840480" cy="164592"/>
+          </a:xfrm>
+          <a:prstGeom prst="rect">
+            <a:avLst/>
+          </a:prstGeom>
+          <a:noFill/>
+          <a:ln/>
+        </p:spPr>
+        <p:txBody>
+          <a:bodyPr wrap="square" lIns="0" tIns="0" rIns="0" bIns="0" rtlCol="0" anchor="ctr"/>
+          <a:lstStyle/>
+          <a:p>
+            <a:pPr marL="0" indent="0">
+              <a:buNone/>
+            </a:pPr>
+            <a:r>
+              <a:rPr lang="en-US" sz="1150" dirty="0">
+                <a:solidFill>
+                  <a:srgbClr val="111827"/>
+                </a:solidFill>
+                <a:latin typeface="Cascadia Mono" pitchFamily="34" charset="0"/>
+                <a:ea typeface="Cascadia Mono" pitchFamily="34" charset="-122"/>
+                <a:cs typeface="Cascadia Mono" pitchFamily="34" charset="-120"/>
+              </a:rPr>
+              <a:t>02_session2_visualization.ipynb</a:t>
+            </a:r>
+            <a:endParaRPr lang="en-US" sz="1150" dirty="0"/>
+          </a:p>
+        </p:txBody>
+      </p:sp>
+    </p:spTree>
+    <p:extLst>
+      <p:ext uri="{BB962C8B-B14F-4D97-AF65-F5344CB8AC3E}">
+        <p14:creationId xmlns:p14="http://schemas.microsoft.com/office/powerpoint/2010/main" val="3959812569"/>
+      </p:ext>
+    </p:extLst>
+  </p:cSld>
+  <p:clrMapOvr>
+    <a:masterClrMapping/>
+  </p:clrMapOvr>
+</p:sld>
+</file>
+
+<file path=ppt/slides/slide14.xml><?xml version="1.0" encoding="utf-8"?>
+<p:sld xmlns:a="http://schemas.openxmlformats.org/drawingml/2006/main" xmlns:r="http://schemas.openxmlformats.org/officeDocument/2006/relationships" xmlns:p="http://schemas.openxmlformats.org/presentationml/2006/main">
+  <p:cSld>
+    <p:bg>
+      <p:bgPr>
+        <a:solidFill>
+          <a:srgbClr val="FBFBFC"/>
+        </a:solidFill>
+        <a:effectLst/>
+      </p:bgPr>
+    </p:bg>
+    <p:spTree>
+      <p:nvGrpSpPr>
+        <p:cNvPr id="1" name="">
+          <a:extLst>
+            <a:ext uri="{FF2B5EF4-FFF2-40B4-BE49-F238E27FC236}">
+              <a16:creationId xmlns:a16="http://schemas.microsoft.com/office/drawing/2014/main" id="{8629DB6C-2763-6A27-C524-A241CF3B240E}"/>
+            </a:ext>
+          </a:extLst>
+        </p:cNvPr>
+        <p:cNvGrpSpPr/>
+        <p:nvPr/>
+      </p:nvGrpSpPr>
+      <p:grpSpPr>
+        <a:xfrm>
+          <a:off x="0" y="0"/>
+          <a:ext cx="0" cy="0"/>
+          <a:chOff x="0" y="0"/>
+          <a:chExt cx="0" cy="0"/>
+        </a:xfrm>
+      </p:grpSpPr>
+      <p:sp>
+        <p:nvSpPr>
+          <p:cNvPr id="2" name="Shape 0">
+            <a:extLst>
+              <a:ext uri="{FF2B5EF4-FFF2-40B4-BE49-F238E27FC236}">
+                <a16:creationId xmlns:a16="http://schemas.microsoft.com/office/drawing/2014/main" id="{EFE0529D-842D-0D6F-C15B-8374EE09E4C2}"/>
+              </a:ext>
+            </a:extLst>
+          </p:cNvPr>
+          <p:cNvSpPr/>
+          <p:nvPr/>
+        </p:nvSpPr>
+        <p:spPr>
+          <a:xfrm>
+            <a:off x="0" y="0"/>
+            <a:ext cx="12191695" cy="201168"/>
+          </a:xfrm>
+          <a:prstGeom prst="rect">
+            <a:avLst/>
+          </a:prstGeom>
+          <a:solidFill>
+            <a:srgbClr val="C8102E"/>
+          </a:solidFill>
+          <a:ln w="12700">
+            <a:solidFill>
+              <a:srgbClr val="C8102E">
+                <a:alpha val="0"/>
+              </a:srgbClr>
+            </a:solidFill>
+            <a:prstDash val="solid"/>
+          </a:ln>
+        </p:spPr>
+        <p:txBody>
+          <a:bodyPr/>
+          <a:lstStyle/>
+          <a:p>
+            <a:endParaRPr lang="en-US"/>
+          </a:p>
+        </p:txBody>
+      </p:sp>
+      <p:sp>
+        <p:nvSpPr>
+          <p:cNvPr id="3" name="Text 1">
+            <a:extLst>
+              <a:ext uri="{FF2B5EF4-FFF2-40B4-BE49-F238E27FC236}">
+                <a16:creationId xmlns:a16="http://schemas.microsoft.com/office/drawing/2014/main" id="{84B5B2AB-4E5D-D1F1-0481-8B63340E36CF}"/>
+              </a:ext>
+            </a:extLst>
+          </p:cNvPr>
+          <p:cNvSpPr/>
+          <p:nvPr/>
+        </p:nvSpPr>
+        <p:spPr>
+          <a:xfrm>
+            <a:off x="502920" y="338328"/>
+            <a:ext cx="4389120" cy="201168"/>
+          </a:xfrm>
+          <a:prstGeom prst="rect">
+            <a:avLst/>
+          </a:prstGeom>
+          <a:noFill/>
+          <a:ln/>
+        </p:spPr>
+        <p:txBody>
+          <a:bodyPr wrap="square" lIns="0" tIns="0" rIns="0" bIns="0" rtlCol="0" anchor="ctr"/>
+          <a:lstStyle/>
+          <a:p>
+            <a:pPr marL="0" indent="0">
+              <a:buNone/>
+            </a:pPr>
+            <a:r>
+              <a:rPr lang="en-US" sz="750" b="1" dirty="0">
+                <a:solidFill>
+                  <a:srgbClr val="6B7280"/>
+                </a:solidFill>
+                <a:latin typeface="Aptos" pitchFamily="34" charset="0"/>
+                <a:ea typeface="Aptos" pitchFamily="34" charset="-122"/>
+                <a:cs typeface="Aptos" pitchFamily="34" charset="-120"/>
+              </a:rPr>
+              <a:t>APPLIED AI DESIGN WORKSHOP</a:t>
+            </a:r>
+            <a:endParaRPr lang="en-US" sz="750" dirty="0"/>
+          </a:p>
+        </p:txBody>
+      </p:sp>
+      <p:sp>
+        <p:nvSpPr>
+          <p:cNvPr id="5" name="Text 3">
+            <a:extLst>
+              <a:ext uri="{FF2B5EF4-FFF2-40B4-BE49-F238E27FC236}">
+                <a16:creationId xmlns:a16="http://schemas.microsoft.com/office/drawing/2014/main" id="{DEBF4B8C-7A50-87FC-F79D-A62491DAB36D}"/>
+              </a:ext>
+            </a:extLst>
+          </p:cNvPr>
+          <p:cNvSpPr/>
+          <p:nvPr/>
+        </p:nvSpPr>
+        <p:spPr>
+          <a:xfrm>
+            <a:off x="10561320" y="420624"/>
+            <a:ext cx="1097280" cy="292608"/>
+          </a:xfrm>
+          <a:prstGeom prst="rect">
+            <a:avLst/>
+          </a:prstGeom>
+          <a:noFill/>
+          <a:ln/>
+        </p:spPr>
+        <p:txBody>
+          <a:bodyPr wrap="square" lIns="0" tIns="0" rIns="0" bIns="0" rtlCol="0" anchor="ctr"/>
+          <a:lstStyle/>
+          <a:p>
+            <a:pPr marL="0" indent="0" algn="r">
+              <a:buNone/>
+            </a:pPr>
+            <a:r>
+              <a:rPr lang="en-US" sz="1000" dirty="0">
+                <a:solidFill>
+                  <a:srgbClr val="6B7280"/>
+                </a:solidFill>
+              </a:rPr>
+              <a:t>Session 2</a:t>
+            </a:r>
+            <a:endParaRPr lang="en-US" sz="1000" dirty="0"/>
+          </a:p>
+        </p:txBody>
+      </p:sp>
+      <p:sp>
+        <p:nvSpPr>
+          <p:cNvPr id="19" name="Text 17">
+            <a:extLst>
+              <a:ext uri="{FF2B5EF4-FFF2-40B4-BE49-F238E27FC236}">
+                <a16:creationId xmlns:a16="http://schemas.microsoft.com/office/drawing/2014/main" id="{97653BFE-5134-7E16-62D2-0CE9E0E99C68}"/>
+              </a:ext>
+            </a:extLst>
+          </p:cNvPr>
+          <p:cNvSpPr/>
+          <p:nvPr/>
+        </p:nvSpPr>
+        <p:spPr>
+          <a:xfrm>
+            <a:off x="11539728" y="6446520"/>
+            <a:ext cx="274320" cy="182880"/>
+          </a:xfrm>
+          <a:prstGeom prst="rect">
+            <a:avLst/>
+          </a:prstGeom>
+          <a:noFill/>
+          <a:ln/>
+        </p:spPr>
+        <p:txBody>
+          <a:bodyPr wrap="square" lIns="0" tIns="0" rIns="0" bIns="0" rtlCol="0" anchor="ctr"/>
+          <a:lstStyle/>
+          <a:p>
+            <a:pPr marL="0" indent="0" algn="r">
+              <a:buNone/>
+            </a:pPr>
+            <a:r>
+              <a:rPr lang="en-US" sz="800" dirty="0">
+                <a:solidFill>
+                  <a:srgbClr val="9CA3AF"/>
+                </a:solidFill>
+              </a:rPr>
+              <a:t>15</a:t>
+            </a:r>
+            <a:endParaRPr lang="en-US" sz="800" dirty="0"/>
+          </a:p>
+        </p:txBody>
+      </p:sp>
+      <p:sp>
+        <p:nvSpPr>
+          <p:cNvPr id="6" name="Text 0">
+            <a:extLst>
+              <a:ext uri="{FF2B5EF4-FFF2-40B4-BE49-F238E27FC236}">
+                <a16:creationId xmlns:a16="http://schemas.microsoft.com/office/drawing/2014/main" id="{0C7F79B1-5EC4-50E7-313F-FABD07266EA1}"/>
+              </a:ext>
+            </a:extLst>
+          </p:cNvPr>
+          <p:cNvSpPr/>
+          <p:nvPr/>
+        </p:nvSpPr>
+        <p:spPr>
+          <a:xfrm>
+            <a:off x="457200" y="758952"/>
+            <a:ext cx="10789920" cy="457200"/>
+          </a:xfrm>
+          <a:prstGeom prst="rect">
+            <a:avLst/>
+          </a:prstGeom>
+          <a:noFill/>
+          <a:ln/>
+        </p:spPr>
+        <p:txBody>
+          <a:bodyPr wrap="square" lIns="0" tIns="0" rIns="0" bIns="0" rtlCol="0" anchor="ctr">
+            <a:normAutofit/>
+          </a:bodyPr>
+          <a:lstStyle/>
+          <a:p>
+            <a:pPr marL="0" indent="0">
+              <a:buNone/>
+            </a:pPr>
+            <a:r>
+              <a:rPr lang="en-US" sz="2500" b="1" dirty="0">
+                <a:solidFill>
+                  <a:srgbClr val="12355B"/>
+                </a:solidFill>
+                <a:latin typeface="Aptos Display" pitchFamily="34" charset="0"/>
+                <a:ea typeface="Aptos Display" pitchFamily="34" charset="-122"/>
+                <a:cs typeface="Aptos Display" pitchFamily="34" charset="-120"/>
+              </a:rPr>
+              <a:t>Three reuse throughout the workshop</a:t>
+            </a:r>
+            <a:endParaRPr lang="en-US" sz="2500" dirty="0"/>
+          </a:p>
+        </p:txBody>
+      </p:sp>
+      <p:sp>
+        <p:nvSpPr>
+          <p:cNvPr id="8" name="Text 1">
+            <a:extLst>
+              <a:ext uri="{FF2B5EF4-FFF2-40B4-BE49-F238E27FC236}">
+                <a16:creationId xmlns:a16="http://schemas.microsoft.com/office/drawing/2014/main" id="{A257C333-E2FA-AA3A-FAB1-A4039006DF2E}"/>
+              </a:ext>
+            </a:extLst>
+          </p:cNvPr>
+          <p:cNvSpPr/>
+          <p:nvPr/>
+        </p:nvSpPr>
+        <p:spPr>
+          <a:xfrm>
+            <a:off x="475488" y="1280160"/>
+            <a:ext cx="10241280" cy="320040"/>
+          </a:xfrm>
+          <a:prstGeom prst="rect">
+            <a:avLst/>
+          </a:prstGeom>
+          <a:noFill/>
+          <a:ln/>
+        </p:spPr>
+        <p:txBody>
+          <a:bodyPr wrap="square" lIns="0" tIns="0" rIns="0" bIns="0" rtlCol="0" anchor="ctr">
+            <a:normAutofit/>
+          </a:bodyPr>
+          <a:lstStyle/>
+          <a:p>
+            <a:pPr marL="0" indent="0">
+              <a:buNone/>
+            </a:pPr>
+            <a:r>
+              <a:rPr lang="en-US" sz="1150" dirty="0">
+                <a:solidFill>
+                  <a:srgbClr val="4B5563"/>
+                </a:solidFill>
+              </a:rPr>
+              <a:t>Use only the plots that support the applied modeling decision.</a:t>
+            </a:r>
+            <a:endParaRPr lang="en-US" sz="1150" dirty="0"/>
+          </a:p>
+        </p:txBody>
+      </p:sp>
+      <p:pic>
+        <p:nvPicPr>
+          <p:cNvPr id="10" name="Image 0" descr="/mnt/data/session0_python_data_tools/assets/iris_scatter.png">
+            <a:extLst>
+              <a:ext uri="{FF2B5EF4-FFF2-40B4-BE49-F238E27FC236}">
+                <a16:creationId xmlns:a16="http://schemas.microsoft.com/office/drawing/2014/main" id="{77E409DE-64C7-DAB7-1806-C5DA4E8D6052}"/>
+              </a:ext>
+            </a:extLst>
+          </p:cNvPr>
+          <p:cNvPicPr>
+            <a:picLocks noChangeAspect="1"/>
+          </p:cNvPicPr>
+          <p:nvPr/>
+        </p:nvPicPr>
+        <p:blipFill>
+          <a:blip r:embed="rId3"/>
+          <a:srcRect l="2830" r="2830"/>
+          <a:stretch/>
+        </p:blipFill>
+        <p:spPr>
+          <a:xfrm>
+            <a:off x="566928" y="1737360"/>
+            <a:ext cx="3200400" cy="2423160"/>
+          </a:xfrm>
+          <a:prstGeom prst="rect">
+            <a:avLst/>
+          </a:prstGeom>
+        </p:spPr>
+      </p:pic>
+      <p:pic>
+        <p:nvPicPr>
+          <p:cNvPr id="12" name="Image 1" descr="/mnt/data/session0_python_data_tools/assets/iris_hist.png">
+            <a:extLst>
+              <a:ext uri="{FF2B5EF4-FFF2-40B4-BE49-F238E27FC236}">
+                <a16:creationId xmlns:a16="http://schemas.microsoft.com/office/drawing/2014/main" id="{4449261C-2936-74D2-F9B8-46468E589B63}"/>
+              </a:ext>
+            </a:extLst>
+          </p:cNvPr>
+          <p:cNvPicPr>
+            <a:picLocks noChangeAspect="1"/>
+          </p:cNvPicPr>
+          <p:nvPr/>
+        </p:nvPicPr>
+        <p:blipFill>
+          <a:blip r:embed="rId4"/>
+          <a:srcRect l="7547" r="7547"/>
+          <a:stretch/>
+        </p:blipFill>
+        <p:spPr>
+          <a:xfrm>
+            <a:off x="4389120" y="1737360"/>
+            <a:ext cx="3200400" cy="2423160"/>
+          </a:xfrm>
+          <a:prstGeom prst="rect">
+            <a:avLst/>
+          </a:prstGeom>
+        </p:spPr>
+      </p:pic>
+      <p:pic>
+        <p:nvPicPr>
+          <p:cNvPr id="14" name="Image 2" descr="/mnt/data/session0_python_data_tools/assets/iris_count.png">
+            <a:extLst>
+              <a:ext uri="{FF2B5EF4-FFF2-40B4-BE49-F238E27FC236}">
+                <a16:creationId xmlns:a16="http://schemas.microsoft.com/office/drawing/2014/main" id="{0004C179-82BC-32DB-2E0E-C7CAFFB7BD54}"/>
+              </a:ext>
+            </a:extLst>
+          </p:cNvPr>
+          <p:cNvPicPr>
+            <a:picLocks noChangeAspect="1"/>
+          </p:cNvPicPr>
+          <p:nvPr/>
+        </p:nvPicPr>
+        <p:blipFill>
+          <a:blip r:embed="rId5"/>
+          <a:srcRect l="472" r="472"/>
+          <a:stretch/>
+        </p:blipFill>
+        <p:spPr>
+          <a:xfrm>
+            <a:off x="8183880" y="1737360"/>
+            <a:ext cx="3200400" cy="2423160"/>
+          </a:xfrm>
+          <a:prstGeom prst="rect">
+            <a:avLst/>
+          </a:prstGeom>
+        </p:spPr>
+      </p:pic>
+      <p:sp>
+        <p:nvSpPr>
+          <p:cNvPr id="16" name="Text 2">
+            <a:extLst>
+              <a:ext uri="{FF2B5EF4-FFF2-40B4-BE49-F238E27FC236}">
+                <a16:creationId xmlns:a16="http://schemas.microsoft.com/office/drawing/2014/main" id="{91BD52C1-8013-D748-D283-C124EB63753C}"/>
+              </a:ext>
+            </a:extLst>
+          </p:cNvPr>
+          <p:cNvSpPr/>
+          <p:nvPr/>
+        </p:nvSpPr>
+        <p:spPr>
+          <a:xfrm>
+            <a:off x="594360" y="4416552"/>
+            <a:ext cx="3108960" cy="365760"/>
+          </a:xfrm>
+          <a:prstGeom prst="rect">
+            <a:avLst/>
+          </a:prstGeom>
+          <a:noFill/>
+          <a:ln/>
+        </p:spPr>
+        <p:txBody>
+          <a:bodyPr wrap="square" lIns="0" tIns="0" rIns="0" bIns="0" rtlCol="0" anchor="ctr"/>
+          <a:lstStyle/>
+          <a:p>
+            <a:pPr marL="0" indent="0" algn="ctr">
+              <a:buNone/>
+            </a:pPr>
+            <a:r>
+              <a:rPr lang="en-US" sz="1300" b="1" dirty="0">
+                <a:solidFill>
+                  <a:srgbClr val="2F80ED"/>
+                </a:solidFill>
+              </a:rPr>
+              <a:t>Scatterplot</a:t>
+            </a:r>
+            <a:endParaRPr lang="en-US" sz="1300" dirty="0"/>
+          </a:p>
+          <a:p>
+            <a:pPr marL="0" indent="0" algn="ctr">
+              <a:buNone/>
+            </a:pPr>
+            <a:r>
+              <a:rPr lang="en-US" sz="1300" b="1" dirty="0">
+                <a:solidFill>
+                  <a:srgbClr val="2F80ED"/>
+                </a:solidFill>
+              </a:rPr>
+              <a:t>relationship + separability</a:t>
+            </a:r>
+            <a:endParaRPr lang="en-US" sz="1300" dirty="0"/>
+          </a:p>
+        </p:txBody>
+      </p:sp>
+      <p:sp>
+        <p:nvSpPr>
+          <p:cNvPr id="18" name="Text 3">
+            <a:extLst>
+              <a:ext uri="{FF2B5EF4-FFF2-40B4-BE49-F238E27FC236}">
+                <a16:creationId xmlns:a16="http://schemas.microsoft.com/office/drawing/2014/main" id="{66BB82CE-715D-8BB0-7A3F-97BD54B3E921}"/>
+              </a:ext>
+            </a:extLst>
+          </p:cNvPr>
+          <p:cNvSpPr/>
+          <p:nvPr/>
+        </p:nvSpPr>
+        <p:spPr>
+          <a:xfrm>
+            <a:off x="4434840" y="4416552"/>
+            <a:ext cx="3108960" cy="365760"/>
+          </a:xfrm>
+          <a:prstGeom prst="rect">
+            <a:avLst/>
+          </a:prstGeom>
+          <a:noFill/>
+          <a:ln/>
+        </p:spPr>
+        <p:txBody>
+          <a:bodyPr wrap="square" lIns="0" tIns="0" rIns="0" bIns="0" rtlCol="0" anchor="ctr"/>
+          <a:lstStyle/>
+          <a:p>
+            <a:pPr marL="0" indent="0" algn="ctr">
+              <a:buNone/>
+            </a:pPr>
+            <a:r>
+              <a:rPr lang="en-US" sz="1300" b="1" dirty="0">
+                <a:solidFill>
+                  <a:srgbClr val="0E7490"/>
+                </a:solidFill>
+              </a:rPr>
+              <a:t>Histogram</a:t>
+            </a:r>
+            <a:endParaRPr lang="en-US" sz="1300" dirty="0"/>
+          </a:p>
+          <a:p>
+            <a:pPr marL="0" indent="0" algn="ctr">
+              <a:buNone/>
+            </a:pPr>
+            <a:r>
+              <a:rPr lang="en-US" sz="1300" b="1" dirty="0">
+                <a:solidFill>
+                  <a:srgbClr val="0E7490"/>
+                </a:solidFill>
+              </a:rPr>
+              <a:t>distribution + overlap</a:t>
+            </a:r>
+            <a:endParaRPr lang="en-US" sz="1300" dirty="0"/>
+          </a:p>
+        </p:txBody>
+      </p:sp>
+      <p:sp>
+        <p:nvSpPr>
+          <p:cNvPr id="22" name="Text 4">
+            <a:extLst>
+              <a:ext uri="{FF2B5EF4-FFF2-40B4-BE49-F238E27FC236}">
+                <a16:creationId xmlns:a16="http://schemas.microsoft.com/office/drawing/2014/main" id="{4B256B3A-B651-84ED-43BB-E68989C20BEA}"/>
+              </a:ext>
+            </a:extLst>
+          </p:cNvPr>
+          <p:cNvSpPr/>
+          <p:nvPr/>
+        </p:nvSpPr>
+        <p:spPr>
+          <a:xfrm>
+            <a:off x="8229600" y="4416552"/>
+            <a:ext cx="3108960" cy="365760"/>
+          </a:xfrm>
+          <a:prstGeom prst="rect">
+            <a:avLst/>
+          </a:prstGeom>
+          <a:noFill/>
+          <a:ln/>
+        </p:spPr>
+        <p:txBody>
+          <a:bodyPr wrap="square" lIns="0" tIns="0" rIns="0" bIns="0" rtlCol="0" anchor="ctr"/>
+          <a:lstStyle/>
+          <a:p>
+            <a:pPr marL="0" indent="0" algn="ctr">
+              <a:buNone/>
+            </a:pPr>
+            <a:r>
+              <a:rPr lang="en-US" sz="1300" b="1" dirty="0">
+                <a:solidFill>
+                  <a:srgbClr val="F97316"/>
+                </a:solidFill>
+              </a:rPr>
+              <a:t>Count plot</a:t>
+            </a:r>
+            <a:endParaRPr lang="en-US" sz="1300" dirty="0"/>
+          </a:p>
+          <a:p>
+            <a:pPr marL="0" indent="0" algn="ctr">
+              <a:buNone/>
+            </a:pPr>
+            <a:r>
+              <a:rPr lang="en-US" sz="1300" b="1" dirty="0">
+                <a:solidFill>
+                  <a:srgbClr val="F97316"/>
+                </a:solidFill>
+              </a:rPr>
+              <a:t>target balance</a:t>
+            </a:r>
+            <a:endParaRPr lang="en-US" sz="1300" dirty="0"/>
+          </a:p>
+        </p:txBody>
+      </p:sp>
+      <p:sp>
+        <p:nvSpPr>
+          <p:cNvPr id="26" name="Text 5">
+            <a:extLst>
+              <a:ext uri="{FF2B5EF4-FFF2-40B4-BE49-F238E27FC236}">
+                <a16:creationId xmlns:a16="http://schemas.microsoft.com/office/drawing/2014/main" id="{2D31BEA7-78D3-E93C-8F3B-CD013B7E6215}"/>
+              </a:ext>
+            </a:extLst>
+          </p:cNvPr>
+          <p:cNvSpPr/>
+          <p:nvPr/>
+        </p:nvSpPr>
+        <p:spPr>
+          <a:xfrm>
+            <a:off x="731520" y="5605272"/>
+            <a:ext cx="10515600" cy="256032"/>
+          </a:xfrm>
+          <a:prstGeom prst="rect">
+            <a:avLst/>
+          </a:prstGeom>
+          <a:noFill/>
+          <a:ln/>
+        </p:spPr>
+        <p:txBody>
+          <a:bodyPr wrap="square" lIns="0" tIns="0" rIns="0" bIns="0" rtlCol="0" anchor="ctr"/>
+          <a:lstStyle/>
+          <a:p>
+            <a:pPr marL="0" indent="0">
+              <a:buNone/>
+            </a:pPr>
+            <a:r>
+              <a:rPr lang="en-US" sz="1500" b="1" dirty="0">
+                <a:solidFill>
+                  <a:srgbClr val="12355B"/>
+                </a:solidFill>
+              </a:rPr>
+              <a:t>Instructor prompt</a:t>
+            </a:r>
+            <a:endParaRPr lang="en-US" sz="1500" dirty="0"/>
+          </a:p>
+        </p:txBody>
+      </p:sp>
+      <p:sp>
+        <p:nvSpPr>
+          <p:cNvPr id="30" name="Text 6">
+            <a:extLst>
+              <a:ext uri="{FF2B5EF4-FFF2-40B4-BE49-F238E27FC236}">
+                <a16:creationId xmlns:a16="http://schemas.microsoft.com/office/drawing/2014/main" id="{107E6AEB-943E-DE66-B3E8-C388DC74781E}"/>
+              </a:ext>
+            </a:extLst>
+          </p:cNvPr>
+          <p:cNvSpPr/>
+          <p:nvPr/>
+        </p:nvSpPr>
+        <p:spPr>
+          <a:xfrm>
+            <a:off x="731520" y="5943600"/>
+            <a:ext cx="10515600" cy="301752"/>
+          </a:xfrm>
+          <a:prstGeom prst="rect">
+            <a:avLst/>
+          </a:prstGeom>
+          <a:noFill/>
+          <a:ln/>
+        </p:spPr>
+        <p:txBody>
+          <a:bodyPr wrap="square" lIns="254" tIns="254" rIns="254" bIns="254" rtlCol="0" anchor="ctr">
+            <a:normAutofit/>
+          </a:bodyPr>
+          <a:lstStyle/>
+          <a:p>
+            <a:pPr marL="0" indent="0">
+              <a:buNone/>
+            </a:pPr>
+            <a:r>
+              <a:rPr lang="en-US" sz="1250" dirty="0">
+                <a:solidFill>
+                  <a:srgbClr val="4B5563"/>
+                </a:solidFill>
+              </a:rPr>
+              <a:t>“Use the plot to decide what question to ask next. Do not treat visualization as proof of causality or final model performance.”</a:t>
+            </a:r>
+            <a:endParaRPr lang="en-US" sz="1250" dirty="0"/>
+          </a:p>
+        </p:txBody>
+      </p:sp>
+    </p:spTree>
+    <p:extLst>
+      <p:ext uri="{BB962C8B-B14F-4D97-AF65-F5344CB8AC3E}">
+        <p14:creationId xmlns:p14="http://schemas.microsoft.com/office/powerpoint/2010/main" val="2503707660"/>
+      </p:ext>
+    </p:extLst>
+  </p:cSld>
+  <p:clrMapOvr>
+    <a:masterClrMapping/>
+  </p:clrMapOvr>
+</p:sld>
+</file>
+
+<file path=ppt/slides/slide15.xml><?xml version="1.0" encoding="utf-8"?>
+<p:sld xmlns:a="http://schemas.openxmlformats.org/drawingml/2006/main" xmlns:r="http://schemas.openxmlformats.org/officeDocument/2006/relationships" xmlns:p="http://schemas.openxmlformats.org/presentationml/2006/main">
   <p:cSld name="Slide 13">
     <p:bg>
       <p:bgPr>
@@ -5981,7 +7601,7 @@
 </p:sld>
 </file>
 
-<file path=ppt/slides/slide14.xml><?xml version="1.0" encoding="utf-8"?>
+<file path=ppt/slides/slide16.xml><?xml version="1.0" encoding="utf-8"?>
 <p:sld xmlns:a="http://schemas.openxmlformats.org/drawingml/2006/main" xmlns:r="http://schemas.openxmlformats.org/officeDocument/2006/relationships" xmlns:p="http://schemas.openxmlformats.org/presentationml/2006/main">
   <p:cSld name="Slide 14">
     <p:bg>
@@ -6740,7 +8360,7 @@
 </p:sld>
 </file>
 
-<file path=ppt/slides/slide15.xml><?xml version="1.0" encoding="utf-8"?>
+<file path=ppt/slides/slide17.xml><?xml version="1.0" encoding="utf-8"?>
 <p:sld xmlns:a="http://schemas.openxmlformats.org/drawingml/2006/main" xmlns:r="http://schemas.openxmlformats.org/officeDocument/2006/relationships" xmlns:p="http://schemas.openxmlformats.org/presentationml/2006/main">
   <p:cSld name="Slide 15">
     <p:bg>
@@ -7427,7 +9047,7 @@
 </p:sld>
 </file>
 
-<file path=ppt/slides/slide16.xml><?xml version="1.0" encoding="utf-8"?>
+<file path=ppt/slides/slide18.xml><?xml version="1.0" encoding="utf-8"?>
 <p:sld xmlns:a="http://schemas.openxmlformats.org/drawingml/2006/main" xmlns:r="http://schemas.openxmlformats.org/officeDocument/2006/relationships" xmlns:p="http://schemas.openxmlformats.org/presentationml/2006/main">
   <p:cSld name="Slide 16">
     <p:bg>

</xml_diff>